<commit_message>
uploaded lab3 instructions and updated slides
</commit_message>
<xml_diff>
--- a/file_system/file_systems.pptx
+++ b/file_system/file_systems.pptx
@@ -3535,6 +3535,27 @@
               <a:t> boot programs from the EFI System Partition.</a:t>
             </a:r>
           </a:p>
+          <a:p>
+            <a:endParaRPr lang="en-US" dirty="0"/>
+          </a:p>
+          <a:p>
+            <a:r>
+              <a:rPr lang="en-US" sz="1200" b="0" u="none" strike="noStrike" kern="1200" dirty="0">
+                <a:solidFill>
+                  <a:schemeClr val="tx1"/>
+                </a:solidFill>
+                <a:effectLst/>
+                <a:latin typeface="Times New Roman" pitchFamily="18" charset="0"/>
+                <a:ea typeface="MS PGothic" pitchFamily="34" charset="-128"/>
+                <a:cs typeface="ＭＳ Ｐゴシック" charset="0"/>
+              </a:rPr>
+              <a:t>Firmware is </a:t>
+            </a:r>
+            <a:r>
+              <a:rPr lang="en-US" dirty="0"/>
+              <a:t>a specialized type of software permanently or semi-permanently embedded directly into hardware devices to provide low-level control and basic operating instructions</a:t>
+            </a:r>
+          </a:p>
         </p:txBody>
       </p:sp>
       <p:sp>
@@ -8286,6 +8307,54 @@
               <a:rPr lang="en-US" sz="1200" dirty="0"/>
               <a:t>+ (2048 * 2048 * 2048 * 8 /KB) = 64 terabytes</a:t>
             </a:r>
+          </a:p>
+          <a:p>
+            <a:pPr marL="0" marR="0" lvl="0" indent="0" algn="l" defTabSz="914400" rtl="0" eaLnBrk="0" fontAlgn="base" latinLnBrk="0" hangingPunct="0">
+              <a:lnSpc>
+                <a:spcPct val="100000"/>
+              </a:lnSpc>
+              <a:spcBef>
+                <a:spcPct val="30000"/>
+              </a:spcBef>
+              <a:spcAft>
+                <a:spcPct val="0"/>
+              </a:spcAft>
+              <a:buClrTx/>
+              <a:buSzTx/>
+              <a:buFontTx/>
+              <a:buNone/>
+              <a:tabLst/>
+              <a:defRPr/>
+            </a:pPr>
+            <a:endParaRPr lang="en-US" sz="1200" dirty="0"/>
+          </a:p>
+          <a:p>
+            <a:pPr marL="0" marR="0" lvl="0" indent="0" algn="l" defTabSz="914400" rtl="0" eaLnBrk="0" fontAlgn="base" latinLnBrk="0" hangingPunct="0">
+              <a:lnSpc>
+                <a:spcPct val="100000"/>
+              </a:lnSpc>
+              <a:spcBef>
+                <a:spcPct val="30000"/>
+              </a:spcBef>
+              <a:spcAft>
+                <a:spcPct val="0"/>
+              </a:spcAft>
+              <a:buClrTx/>
+              <a:buSzTx/>
+              <a:buFontTx/>
+              <a:buNone/>
+              <a:tabLst/>
+              <a:defRPr/>
+            </a:pPr>
+            <a:r>
+              <a:rPr lang="en-US" sz="1200" dirty="0"/>
+              <a:t>12 * 8 + (2000 * 8) + (2000^2 * 8) = (2000^3 * 8) = 8 * (2000^3 + 2000^2 + 2000 + 12) = 64 032 016 096 ~= </a:t>
+            </a:r>
+            <a:r>
+              <a:rPr lang="en-US" sz="1200"/>
+              <a:t>64 Terabytes</a:t>
+            </a:r>
+            <a:endParaRPr lang="en-US" sz="1200" dirty="0"/>
           </a:p>
         </p:txBody>
       </p:sp>
@@ -20138,14 +20207,14 @@
           </a:ln>
           <a:extLst>
             <a:ext uri="{909E8E84-426E-40dd-AFC4-6F175D3DCCD1}">
-              <a14:hiddenFill xmlns="" xmlns:a14="http://schemas.microsoft.com/office/drawing/2010/main">
+              <a14:hiddenFill xmlns:a14="http://schemas.microsoft.com/office/drawing/2010/main" xmlns="">
                 <a:solidFill>
                   <a:srgbClr val="FFFFFF"/>
                 </a:solidFill>
               </a14:hiddenFill>
             </a:ext>
             <a:ext uri="{91240B29-F687-4f45-9708-019B960494DF}">
-              <a14:hiddenLine xmlns="" xmlns:a14="http://schemas.microsoft.com/office/drawing/2010/main" w="9525">
+              <a14:hiddenLine xmlns:a14="http://schemas.microsoft.com/office/drawing/2010/main" xmlns="" w="9525">
                 <a:solidFill>
                   <a:srgbClr val="000000"/>
                 </a:solidFill>

</xml_diff>